<commit_message>
Refactor design tokens and components to remove references to `--text-secondary`, replacing with `--text-primary` for consistency in text color usage across the design system. Update documentation to clarify color usage guidelines and accessibility standards.
</commit_message>
<xml_diff>
--- a/brand-editable/public-ai-logo-editable.pptx
+++ b/brand-editable/public-ai-logo-editable.pptx
@@ -5,11 +5,11 @@
     <p:sldMasterId id="2147483648" r:id="rId1"/>
   </p:sldMasterIdLst>
   <p:sldIdLst>
-    <p:sldId id="256" r:id="rId7"/>
-    <p:sldId id="257" r:id="rId8"/>
-    <p:sldId id="258" r:id="rId9"/>
+    <p:sldId id="256" r:id="rId2"/>
+    <p:sldId id="257" r:id="rId3"/>
+    <p:sldId id="258" r:id="rId4"/>
   </p:sldIdLst>
-  <p:sldSz cx="12191695" cy="6858000" type="screen4x3"/>
+  <p:sldSz cx="12192000" cy="6858000"/>
   <p:notesSz cx="6858000" cy="9144000"/>
   <p:defaultTextStyle>
     <a:defPPr>
@@ -106,6 +106,22 @@
       </a:defRPr>
     </a:lvl9pPr>
   </p:defaultTextStyle>
+  <p:extLst>
+    <p:ext uri="{EFAFB233-063F-42B5-8137-9DF3F51BA10A}">
+      <p15:sldGuideLst xmlns:p15="http://schemas.microsoft.com/office/powerpoint/2012/main">
+        <p15:guide id="1" orient="horz" pos="2160">
+          <p15:clr>
+            <a:srgbClr val="A4A3A4"/>
+          </p15:clr>
+        </p15:guide>
+        <p15:guide id="2" pos="2880">
+          <p15:clr>
+            <a:srgbClr val="A4A3A4"/>
+          </p15:clr>
+        </p15:guide>
+      </p15:sldGuideLst>
+    </p:ext>
+  </p:extLst>
 </p:presentation>
 </file>
 
@@ -147,10 +163,9 @@
           <a:lstStyle/>
           <a:p>
             <a:r>
-              <a:rPr lang="en-US" smtClean="0"/>
+              <a:rPr lang="en-US"/>
               <a:t>Click to edit Master title style</a:t>
             </a:r>
-            <a:endParaRPr lang="en-US"/>
           </a:p>
         </p:txBody>
       </p:sp>
@@ -266,10 +281,9 @@
           </a:lstStyle>
           <a:p>
             <a:r>
-              <a:rPr lang="en-US" smtClean="0"/>
+              <a:rPr lang="en-US"/>
               <a:t>Click to edit Master subtitle style</a:t>
             </a:r>
-            <a:endParaRPr lang="en-US"/>
           </a:p>
         </p:txBody>
       </p:sp>
@@ -290,7 +304,7 @@
           <a:p>
             <a:fld id="{5BCAD085-E8A6-8845-BD4E-CB4CCA059FC4}" type="datetimeFigureOut">
               <a:rPr lang="en-US" smtClean="0"/>
-              <a:t>1/27/13</a:t>
+              <a:t>7/25/26</a:t>
             </a:fld>
             <a:endParaRPr lang="en-US"/>
           </a:p>
@@ -384,10 +398,9 @@
           <a:lstStyle/>
           <a:p>
             <a:r>
-              <a:rPr lang="en-US" smtClean="0"/>
+              <a:rPr lang="en-US"/>
               <a:t>Click to edit Master title style</a:t>
             </a:r>
-            <a:endParaRPr lang="en-US"/>
           </a:p>
         </p:txBody>
       </p:sp>
@@ -408,38 +421,37 @@
           <a:p>
             <a:pPr lvl="0"/>
             <a:r>
-              <a:rPr lang="en-US" smtClean="0"/>
+              <a:rPr lang="en-US"/>
               <a:t>Click to edit Master text styles</a:t>
             </a:r>
           </a:p>
           <a:p>
             <a:pPr lvl="1"/>
             <a:r>
-              <a:rPr lang="en-US" smtClean="0"/>
+              <a:rPr lang="en-US"/>
               <a:t>Second level</a:t>
             </a:r>
           </a:p>
           <a:p>
             <a:pPr lvl="2"/>
             <a:r>
-              <a:rPr lang="en-US" smtClean="0"/>
+              <a:rPr lang="en-US"/>
               <a:t>Third level</a:t>
             </a:r>
           </a:p>
           <a:p>
             <a:pPr lvl="3"/>
             <a:r>
-              <a:rPr lang="en-US" smtClean="0"/>
+              <a:rPr lang="en-US"/>
               <a:t>Fourth level</a:t>
             </a:r>
           </a:p>
           <a:p>
             <a:pPr lvl="4"/>
             <a:r>
-              <a:rPr lang="en-US" smtClean="0"/>
+              <a:rPr lang="en-US"/>
               <a:t>Fifth level</a:t>
             </a:r>
-            <a:endParaRPr lang="en-US"/>
           </a:p>
         </p:txBody>
       </p:sp>
@@ -460,7 +472,7 @@
           <a:p>
             <a:fld id="{5BCAD085-E8A6-8845-BD4E-CB4CCA059FC4}" type="datetimeFigureOut">
               <a:rPr lang="en-US" smtClean="0"/>
-              <a:t>1/27/13</a:t>
+              <a:t>7/25/26</a:t>
             </a:fld>
             <a:endParaRPr lang="en-US"/>
           </a:p>
@@ -559,10 +571,9 @@
           <a:lstStyle/>
           <a:p>
             <a:r>
-              <a:rPr lang="en-US" smtClean="0"/>
+              <a:rPr lang="en-US"/>
               <a:t>Click to edit Master title style</a:t>
             </a:r>
-            <a:endParaRPr lang="en-US"/>
           </a:p>
         </p:txBody>
       </p:sp>
@@ -588,38 +599,37 @@
           <a:p>
             <a:pPr lvl="0"/>
             <a:r>
-              <a:rPr lang="en-US" smtClean="0"/>
+              <a:rPr lang="en-US"/>
               <a:t>Click to edit Master text styles</a:t>
             </a:r>
           </a:p>
           <a:p>
             <a:pPr lvl="1"/>
             <a:r>
-              <a:rPr lang="en-US" smtClean="0"/>
+              <a:rPr lang="en-US"/>
               <a:t>Second level</a:t>
             </a:r>
           </a:p>
           <a:p>
             <a:pPr lvl="2"/>
             <a:r>
-              <a:rPr lang="en-US" smtClean="0"/>
+              <a:rPr lang="en-US"/>
               <a:t>Third level</a:t>
             </a:r>
           </a:p>
           <a:p>
             <a:pPr lvl="3"/>
             <a:r>
-              <a:rPr lang="en-US" smtClean="0"/>
+              <a:rPr lang="en-US"/>
               <a:t>Fourth level</a:t>
             </a:r>
           </a:p>
           <a:p>
             <a:pPr lvl="4"/>
             <a:r>
-              <a:rPr lang="en-US" smtClean="0"/>
+              <a:rPr lang="en-US"/>
               <a:t>Fifth level</a:t>
             </a:r>
-            <a:endParaRPr lang="en-US"/>
           </a:p>
         </p:txBody>
       </p:sp>
@@ -640,7 +650,7 @@
           <a:p>
             <a:fld id="{5BCAD085-E8A6-8845-BD4E-CB4CCA059FC4}" type="datetimeFigureOut">
               <a:rPr lang="en-US" smtClean="0"/>
-              <a:t>1/27/13</a:t>
+              <a:t>7/25/26</a:t>
             </a:fld>
             <a:endParaRPr lang="en-US"/>
           </a:p>
@@ -734,10 +744,9 @@
           <a:lstStyle/>
           <a:p>
             <a:r>
-              <a:rPr lang="en-US" smtClean="0"/>
+              <a:rPr lang="en-US"/>
               <a:t>Click to edit Master title style</a:t>
             </a:r>
-            <a:endParaRPr lang="en-US"/>
           </a:p>
         </p:txBody>
       </p:sp>
@@ -758,38 +767,37 @@
           <a:p>
             <a:pPr lvl="0"/>
             <a:r>
-              <a:rPr lang="en-US" smtClean="0"/>
+              <a:rPr lang="en-US"/>
               <a:t>Click to edit Master text styles</a:t>
             </a:r>
           </a:p>
           <a:p>
             <a:pPr lvl="1"/>
             <a:r>
-              <a:rPr lang="en-US" smtClean="0"/>
+              <a:rPr lang="en-US"/>
               <a:t>Second level</a:t>
             </a:r>
           </a:p>
           <a:p>
             <a:pPr lvl="2"/>
             <a:r>
-              <a:rPr lang="en-US" smtClean="0"/>
+              <a:rPr lang="en-US"/>
               <a:t>Third level</a:t>
             </a:r>
           </a:p>
           <a:p>
             <a:pPr lvl="3"/>
             <a:r>
-              <a:rPr lang="en-US" smtClean="0"/>
+              <a:rPr lang="en-US"/>
               <a:t>Fourth level</a:t>
             </a:r>
           </a:p>
           <a:p>
             <a:pPr lvl="4"/>
             <a:r>
-              <a:rPr lang="en-US" smtClean="0"/>
+              <a:rPr lang="en-US"/>
               <a:t>Fifth level</a:t>
             </a:r>
-            <a:endParaRPr lang="en-US"/>
           </a:p>
         </p:txBody>
       </p:sp>
@@ -810,7 +818,7 @@
           <a:p>
             <a:fld id="{5BCAD085-E8A6-8845-BD4E-CB4CCA059FC4}" type="datetimeFigureOut">
               <a:rPr lang="en-US" smtClean="0"/>
-              <a:t>1/27/13</a:t>
+              <a:t>7/25/26</a:t>
             </a:fld>
             <a:endParaRPr lang="en-US"/>
           </a:p>
@@ -913,10 +921,9 @@
           </a:lstStyle>
           <a:p>
             <a:r>
-              <a:rPr lang="en-US" smtClean="0"/>
+              <a:rPr lang="en-US"/>
               <a:t>Click to edit Master title style</a:t>
             </a:r>
-            <a:endParaRPr lang="en-US"/>
           </a:p>
         </p:txBody>
       </p:sp>
@@ -1033,7 +1040,7 @@
           <a:p>
             <a:pPr lvl="0"/>
             <a:r>
-              <a:rPr lang="en-US" smtClean="0"/>
+              <a:rPr lang="en-US"/>
               <a:t>Click to edit Master text styles</a:t>
             </a:r>
           </a:p>
@@ -1056,7 +1063,7 @@
           <a:p>
             <a:fld id="{5BCAD085-E8A6-8845-BD4E-CB4CCA059FC4}" type="datetimeFigureOut">
               <a:rPr lang="en-US" smtClean="0"/>
-              <a:t>1/27/13</a:t>
+              <a:t>7/25/26</a:t>
             </a:fld>
             <a:endParaRPr lang="en-US"/>
           </a:p>
@@ -1150,10 +1157,9 @@
           <a:lstStyle/>
           <a:p>
             <a:r>
-              <a:rPr lang="en-US" smtClean="0"/>
+              <a:rPr lang="en-US"/>
               <a:t>Click to edit Master title style</a:t>
             </a:r>
-            <a:endParaRPr lang="en-US"/>
           </a:p>
         </p:txBody>
       </p:sp>
@@ -1207,38 +1213,37 @@
           <a:p>
             <a:pPr lvl="0"/>
             <a:r>
-              <a:rPr lang="en-US" smtClean="0"/>
+              <a:rPr lang="en-US"/>
               <a:t>Click to edit Master text styles</a:t>
             </a:r>
           </a:p>
           <a:p>
             <a:pPr lvl="1"/>
             <a:r>
-              <a:rPr lang="en-US" smtClean="0"/>
+              <a:rPr lang="en-US"/>
               <a:t>Second level</a:t>
             </a:r>
           </a:p>
           <a:p>
             <a:pPr lvl="2"/>
             <a:r>
-              <a:rPr lang="en-US" smtClean="0"/>
+              <a:rPr lang="en-US"/>
               <a:t>Third level</a:t>
             </a:r>
           </a:p>
           <a:p>
             <a:pPr lvl="3"/>
             <a:r>
-              <a:rPr lang="en-US" smtClean="0"/>
+              <a:rPr lang="en-US"/>
               <a:t>Fourth level</a:t>
             </a:r>
           </a:p>
           <a:p>
             <a:pPr lvl="4"/>
             <a:r>
-              <a:rPr lang="en-US" smtClean="0"/>
+              <a:rPr lang="en-US"/>
               <a:t>Fifth level</a:t>
             </a:r>
-            <a:endParaRPr lang="en-US"/>
           </a:p>
         </p:txBody>
       </p:sp>
@@ -1292,38 +1297,37 @@
           <a:p>
             <a:pPr lvl="0"/>
             <a:r>
-              <a:rPr lang="en-US" smtClean="0"/>
+              <a:rPr lang="en-US"/>
               <a:t>Click to edit Master text styles</a:t>
             </a:r>
           </a:p>
           <a:p>
             <a:pPr lvl="1"/>
             <a:r>
-              <a:rPr lang="en-US" smtClean="0"/>
+              <a:rPr lang="en-US"/>
               <a:t>Second level</a:t>
             </a:r>
           </a:p>
           <a:p>
             <a:pPr lvl="2"/>
             <a:r>
-              <a:rPr lang="en-US" smtClean="0"/>
+              <a:rPr lang="en-US"/>
               <a:t>Third level</a:t>
             </a:r>
           </a:p>
           <a:p>
             <a:pPr lvl="3"/>
             <a:r>
-              <a:rPr lang="en-US" smtClean="0"/>
+              <a:rPr lang="en-US"/>
               <a:t>Fourth level</a:t>
             </a:r>
           </a:p>
           <a:p>
             <a:pPr lvl="4"/>
             <a:r>
-              <a:rPr lang="en-US" smtClean="0"/>
+              <a:rPr lang="en-US"/>
               <a:t>Fifth level</a:t>
             </a:r>
-            <a:endParaRPr lang="en-US"/>
           </a:p>
         </p:txBody>
       </p:sp>
@@ -1344,7 +1348,7 @@
           <a:p>
             <a:fld id="{5BCAD085-E8A6-8845-BD4E-CB4CCA059FC4}" type="datetimeFigureOut">
               <a:rPr lang="en-US" smtClean="0"/>
-              <a:t>1/27/13</a:t>
+              <a:t>7/25/26</a:t>
             </a:fld>
             <a:endParaRPr lang="en-US"/>
           </a:p>
@@ -1442,10 +1446,9 @@
           </a:lstStyle>
           <a:p>
             <a:r>
-              <a:rPr lang="en-US" smtClean="0"/>
+              <a:rPr lang="en-US"/>
               <a:t>Click to edit Master title style</a:t>
             </a:r>
-            <a:endParaRPr lang="en-US"/>
           </a:p>
         </p:txBody>
       </p:sp>
@@ -1508,7 +1511,7 @@
           <a:p>
             <a:pPr lvl="0"/>
             <a:r>
-              <a:rPr lang="en-US" smtClean="0"/>
+              <a:rPr lang="en-US"/>
               <a:t>Click to edit Master text styles</a:t>
             </a:r>
           </a:p>
@@ -1564,38 +1567,37 @@
           <a:p>
             <a:pPr lvl="0"/>
             <a:r>
-              <a:rPr lang="en-US" smtClean="0"/>
+              <a:rPr lang="en-US"/>
               <a:t>Click to edit Master text styles</a:t>
             </a:r>
           </a:p>
           <a:p>
             <a:pPr lvl="1"/>
             <a:r>
-              <a:rPr lang="en-US" smtClean="0"/>
+              <a:rPr lang="en-US"/>
               <a:t>Second level</a:t>
             </a:r>
           </a:p>
           <a:p>
             <a:pPr lvl="2"/>
             <a:r>
-              <a:rPr lang="en-US" smtClean="0"/>
+              <a:rPr lang="en-US"/>
               <a:t>Third level</a:t>
             </a:r>
           </a:p>
           <a:p>
             <a:pPr lvl="3"/>
             <a:r>
-              <a:rPr lang="en-US" smtClean="0"/>
+              <a:rPr lang="en-US"/>
               <a:t>Fourth level</a:t>
             </a:r>
           </a:p>
           <a:p>
             <a:pPr lvl="4"/>
             <a:r>
-              <a:rPr lang="en-US" smtClean="0"/>
+              <a:rPr lang="en-US"/>
               <a:t>Fifth level</a:t>
             </a:r>
-            <a:endParaRPr lang="en-US"/>
           </a:p>
         </p:txBody>
       </p:sp>
@@ -1658,7 +1660,7 @@
           <a:p>
             <a:pPr lvl="0"/>
             <a:r>
-              <a:rPr lang="en-US" smtClean="0"/>
+              <a:rPr lang="en-US"/>
               <a:t>Click to edit Master text styles</a:t>
             </a:r>
           </a:p>
@@ -1714,38 +1716,37 @@
           <a:p>
             <a:pPr lvl="0"/>
             <a:r>
-              <a:rPr lang="en-US" smtClean="0"/>
+              <a:rPr lang="en-US"/>
               <a:t>Click to edit Master text styles</a:t>
             </a:r>
           </a:p>
           <a:p>
             <a:pPr lvl="1"/>
             <a:r>
-              <a:rPr lang="en-US" smtClean="0"/>
+              <a:rPr lang="en-US"/>
               <a:t>Second level</a:t>
             </a:r>
           </a:p>
           <a:p>
             <a:pPr lvl="2"/>
             <a:r>
-              <a:rPr lang="en-US" smtClean="0"/>
+              <a:rPr lang="en-US"/>
               <a:t>Third level</a:t>
             </a:r>
           </a:p>
           <a:p>
             <a:pPr lvl="3"/>
             <a:r>
-              <a:rPr lang="en-US" smtClean="0"/>
+              <a:rPr lang="en-US"/>
               <a:t>Fourth level</a:t>
             </a:r>
           </a:p>
           <a:p>
             <a:pPr lvl="4"/>
             <a:r>
-              <a:rPr lang="en-US" smtClean="0"/>
+              <a:rPr lang="en-US"/>
               <a:t>Fifth level</a:t>
             </a:r>
-            <a:endParaRPr lang="en-US"/>
           </a:p>
         </p:txBody>
       </p:sp>
@@ -1766,7 +1767,7 @@
           <a:p>
             <a:fld id="{5BCAD085-E8A6-8845-BD4E-CB4CCA059FC4}" type="datetimeFigureOut">
               <a:rPr lang="en-US" smtClean="0"/>
-              <a:t>1/27/13</a:t>
+              <a:t>7/25/26</a:t>
             </a:fld>
             <a:endParaRPr lang="en-US"/>
           </a:p>
@@ -1860,10 +1861,9 @@
           <a:lstStyle/>
           <a:p>
             <a:r>
-              <a:rPr lang="en-US" smtClean="0"/>
+              <a:rPr lang="en-US"/>
               <a:t>Click to edit Master title style</a:t>
             </a:r>
-            <a:endParaRPr lang="en-US"/>
           </a:p>
         </p:txBody>
       </p:sp>
@@ -1884,7 +1884,7 @@
           <a:p>
             <a:fld id="{5BCAD085-E8A6-8845-BD4E-CB4CCA059FC4}" type="datetimeFigureOut">
               <a:rPr lang="en-US" smtClean="0"/>
-              <a:t>1/27/13</a:t>
+              <a:t>7/25/26</a:t>
             </a:fld>
             <a:endParaRPr lang="en-US"/>
           </a:p>
@@ -1979,7 +1979,7 @@
           <a:p>
             <a:fld id="{5BCAD085-E8A6-8845-BD4E-CB4CCA059FC4}" type="datetimeFigureOut">
               <a:rPr lang="en-US" smtClean="0"/>
-              <a:t>1/27/13</a:t>
+              <a:t>7/25/26</a:t>
             </a:fld>
             <a:endParaRPr lang="en-US"/>
           </a:p>
@@ -2082,10 +2082,9 @@
           </a:lstStyle>
           <a:p>
             <a:r>
-              <a:rPr lang="en-US" smtClean="0"/>
+              <a:rPr lang="en-US"/>
               <a:t>Click to edit Master title style</a:t>
             </a:r>
-            <a:endParaRPr lang="en-US"/>
           </a:p>
         </p:txBody>
       </p:sp>
@@ -2139,38 +2138,37 @@
           <a:p>
             <a:pPr lvl="0"/>
             <a:r>
-              <a:rPr lang="en-US" smtClean="0"/>
+              <a:rPr lang="en-US"/>
               <a:t>Click to edit Master text styles</a:t>
             </a:r>
           </a:p>
           <a:p>
             <a:pPr lvl="1"/>
             <a:r>
-              <a:rPr lang="en-US" smtClean="0"/>
+              <a:rPr lang="en-US"/>
               <a:t>Second level</a:t>
             </a:r>
           </a:p>
           <a:p>
             <a:pPr lvl="2"/>
             <a:r>
-              <a:rPr lang="en-US" smtClean="0"/>
+              <a:rPr lang="en-US"/>
               <a:t>Third level</a:t>
             </a:r>
           </a:p>
           <a:p>
             <a:pPr lvl="3"/>
             <a:r>
-              <a:rPr lang="en-US" smtClean="0"/>
+              <a:rPr lang="en-US"/>
               <a:t>Fourth level</a:t>
             </a:r>
           </a:p>
           <a:p>
             <a:pPr lvl="4"/>
             <a:r>
-              <a:rPr lang="en-US" smtClean="0"/>
+              <a:rPr lang="en-US"/>
               <a:t>Fifth level</a:t>
             </a:r>
-            <a:endParaRPr lang="en-US"/>
           </a:p>
         </p:txBody>
       </p:sp>
@@ -2233,7 +2231,7 @@
           <a:p>
             <a:pPr lvl="0"/>
             <a:r>
-              <a:rPr lang="en-US" smtClean="0"/>
+              <a:rPr lang="en-US"/>
               <a:t>Click to edit Master text styles</a:t>
             </a:r>
           </a:p>
@@ -2256,7 +2254,7 @@
           <a:p>
             <a:fld id="{5BCAD085-E8A6-8845-BD4E-CB4CCA059FC4}" type="datetimeFigureOut">
               <a:rPr lang="en-US" smtClean="0"/>
-              <a:t>1/27/13</a:t>
+              <a:t>7/25/26</a:t>
             </a:fld>
             <a:endParaRPr lang="en-US"/>
           </a:p>
@@ -2359,10 +2357,9 @@
           </a:lstStyle>
           <a:p>
             <a:r>
-              <a:rPr lang="en-US" smtClean="0"/>
+              <a:rPr lang="en-US"/>
               <a:t>Click to edit Master title style</a:t>
             </a:r>
-            <a:endParaRPr lang="en-US"/>
           </a:p>
         </p:txBody>
       </p:sp>
@@ -2486,7 +2483,7 @@
           <a:p>
             <a:pPr lvl="0"/>
             <a:r>
-              <a:rPr lang="en-US" smtClean="0"/>
+              <a:rPr lang="en-US"/>
               <a:t>Click to edit Master text styles</a:t>
             </a:r>
           </a:p>
@@ -2509,7 +2506,7 @@
           <a:p>
             <a:fld id="{5BCAD085-E8A6-8845-BD4E-CB4CCA059FC4}" type="datetimeFigureOut">
               <a:rPr lang="en-US" smtClean="0"/>
-              <a:t>1/27/13</a:t>
+              <a:t>7/25/26</a:t>
             </a:fld>
             <a:endParaRPr lang="en-US"/>
           </a:p>
@@ -2618,10 +2615,9 @@
           <a:lstStyle/>
           <a:p>
             <a:r>
-              <a:rPr lang="en-US" smtClean="0"/>
+              <a:rPr lang="en-US"/>
               <a:t>Click to edit Master title style</a:t>
             </a:r>
-            <a:endParaRPr lang="en-US"/>
           </a:p>
         </p:txBody>
       </p:sp>
@@ -2652,38 +2648,37 @@
           <a:p>
             <a:pPr lvl="0"/>
             <a:r>
-              <a:rPr lang="en-US" smtClean="0"/>
+              <a:rPr lang="en-US"/>
               <a:t>Click to edit Master text styles</a:t>
             </a:r>
           </a:p>
           <a:p>
             <a:pPr lvl="1"/>
             <a:r>
-              <a:rPr lang="en-US" smtClean="0"/>
+              <a:rPr lang="en-US"/>
               <a:t>Second level</a:t>
             </a:r>
           </a:p>
           <a:p>
             <a:pPr lvl="2"/>
             <a:r>
-              <a:rPr lang="en-US" smtClean="0"/>
+              <a:rPr lang="en-US"/>
               <a:t>Third level</a:t>
             </a:r>
           </a:p>
           <a:p>
             <a:pPr lvl="3"/>
             <a:r>
-              <a:rPr lang="en-US" smtClean="0"/>
+              <a:rPr lang="en-US"/>
               <a:t>Fourth level</a:t>
             </a:r>
           </a:p>
           <a:p>
             <a:pPr lvl="4"/>
             <a:r>
-              <a:rPr lang="en-US" smtClean="0"/>
+              <a:rPr lang="en-US"/>
               <a:t>Fifth level</a:t>
             </a:r>
-            <a:endParaRPr lang="en-US"/>
           </a:p>
         </p:txBody>
       </p:sp>
@@ -2722,7 +2717,7 @@
           <a:p>
             <a:fld id="{5BCAD085-E8A6-8845-BD4E-CB4CCA059FC4}" type="datetimeFigureOut">
               <a:rPr lang="en-US" smtClean="0"/>
-              <a:t>1/27/13</a:t>
+              <a:t>7/25/26</a:t>
             </a:fld>
             <a:endParaRPr lang="en-US"/>
           </a:p>
@@ -3081,7 +3076,7 @@
 </file>
 
 <file path=ppt/slides/slide1.xml><?xml version="1.0" encoding="utf-8"?>
-<p:sld xmlns:a="http://schemas.openxmlformats.org/drawingml/2006/main" xmlns:p="http://schemas.openxmlformats.org/presentationml/2006/main" xmlns:r="http://schemas.openxmlformats.org/officeDocument/2006/relationships">
+<p:sld xmlns:a="http://schemas.openxmlformats.org/drawingml/2006/main" xmlns:r="http://schemas.openxmlformats.org/officeDocument/2006/relationships" xmlns:p="http://schemas.openxmlformats.org/presentationml/2006/main">
   <p:cSld>
     <p:spTree>
       <p:nvGrpSpPr>
@@ -3089,50 +3084,14 @@
         <p:cNvGrpSpPr/>
         <p:nvPr/>
       </p:nvGrpSpPr>
-      <p:grpSpPr/>
-      <p:sp>
-        <p:nvSpPr>
-          <p:cNvPr id="2" name="Rectangle 1"/>
-          <p:cNvSpPr/>
-          <p:nvPr/>
-        </p:nvSpPr>
-        <p:spPr>
-          <a:xfrm>
-            <a:off x="0" y="0"/>
-            <a:ext cx="12191695" cy="6858000"/>
-          </a:xfrm>
-          <a:prstGeom prst="rect">
-            <a:avLst/>
-          </a:prstGeom>
-          <a:solidFill>
-            <a:srgbClr val="FFFFFF"/>
-          </a:solidFill>
-          <a:ln>
-            <a:noFill/>
-          </a:ln>
-        </p:spPr>
-        <p:style>
-          <a:lnRef idx="1">
-            <a:schemeClr val="accent1"/>
-          </a:lnRef>
-          <a:fillRef idx="3">
-            <a:schemeClr val="accent1"/>
-          </a:fillRef>
-          <a:effectRef idx="2">
-            <a:schemeClr val="accent1"/>
-          </a:effectRef>
-          <a:fontRef idx="minor">
-            <a:schemeClr val="lt1"/>
-          </a:fontRef>
-        </p:style>
-        <p:txBody>
-          <a:bodyPr rtlCol="0" anchor="ctr"/>
-          <a:lstStyle/>
-          <a:p>
-            <a:pPr algn="ctr"/>
-          </a:p>
-        </p:txBody>
-      </p:sp>
+      <p:grpSpPr>
+        <a:xfrm>
+          <a:off x="0" y="0"/>
+          <a:ext cx="0" cy="0"/>
+          <a:chOff x="0" y="0"/>
+          <a:chExt cx="0" cy="0"/>
+        </a:xfrm>
+      </p:grpSpPr>
       <p:sp>
         <p:nvSpPr>
           <p:cNvPr id="3" name="Rectangle 2"/>
@@ -3173,6 +3132,7 @@
           <a:lstStyle/>
           <a:p>
             <a:pPr algn="ctr"/>
+            <a:endParaRPr/>
           </a:p>
         </p:txBody>
       </p:sp>
@@ -3259,6 +3219,7 @@
           <a:lstStyle/>
           <a:p>
             <a:pPr algn="ctr"/>
+            <a:endParaRPr/>
           </a:p>
         </p:txBody>
       </p:sp>
@@ -3286,7 +3247,7 @@
           <a:p>
             <a:pPr algn="l"/>
             <a:r>
-              <a:rPr sz="3200" b="1">
+              <a:rPr sz="3200" b="1" dirty="0">
                 <a:solidFill>
                   <a:srgbClr val="000000"/>
                 </a:solidFill>
@@ -3321,9 +3282,9 @@
           <a:p>
             <a:pPr algn="l"/>
             <a:r>
-              <a:rPr sz="1600" b="0">
-                <a:solidFill>
-                  <a:srgbClr val="6F6F6F"/>
+              <a:rPr sz="1600" b="0" dirty="0">
+                <a:solidFill>
+                  <a:srgbClr val="000000"/>
                 </a:solidFill>
                 <a:latin typeface="Public Sans"/>
               </a:rPr>
@@ -3372,6 +3333,7 @@
           <a:lstStyle/>
           <a:p>
             <a:pPr algn="ctr"/>
+            <a:endParaRPr/>
           </a:p>
         </p:txBody>
       </p:sp>
@@ -3403,7 +3365,7 @@
               </a:lnSpc>
             </a:pPr>
             <a:r>
-              <a:rPr sz="1300" b="0">
+              <a:rPr sz="1300" b="0" dirty="0">
                 <a:solidFill>
                   <a:srgbClr val="000000"/>
                 </a:solidFill>
@@ -3419,7 +3381,7 @@
               </a:lnSpc>
             </a:pPr>
             <a:r>
-              <a:rPr sz="1300" b="0">
+              <a:rPr sz="1300" b="0" dirty="0">
                 <a:solidFill>
                   <a:srgbClr val="000000"/>
                 </a:solidFill>
@@ -3434,15 +3396,12 @@
                 <a:spcPct val="115000"/>
               </a:lnSpc>
             </a:pPr>
-            <a:r>
-              <a:rPr sz="1300" b="0">
-                <a:solidFill>
-                  <a:srgbClr val="000000"/>
-                </a:solidFill>
-                <a:latin typeface="Public Sans"/>
-              </a:rPr>
-              <a:t/>
-            </a:r>
+            <a:endParaRPr sz="1300" b="0" dirty="0">
+              <a:solidFill>
+                <a:srgbClr val="000000"/>
+              </a:solidFill>
+              <a:latin typeface="Public Sans"/>
+            </a:endParaRPr>
           </a:p>
           <a:p>
             <a:pPr algn="l">
@@ -3451,7 +3410,7 @@
               </a:lnSpc>
             </a:pPr>
             <a:r>
-              <a:rPr sz="1300" b="0">
+              <a:rPr sz="1300" b="0" dirty="0">
                 <a:solidFill>
                   <a:srgbClr val="000000"/>
                 </a:solidFill>
@@ -3467,7 +3426,7 @@
               </a:lnSpc>
             </a:pPr>
             <a:r>
-              <a:rPr sz="1300" b="0">
+              <a:rPr sz="1300" b="0" dirty="0">
                 <a:solidFill>
                   <a:srgbClr val="000000"/>
                 </a:solidFill>
@@ -3483,7 +3442,7 @@
               </a:lnSpc>
             </a:pPr>
             <a:r>
-              <a:rPr sz="1300" b="0">
+              <a:rPr sz="1300" b="0" dirty="0">
                 <a:solidFill>
                   <a:srgbClr val="000000"/>
                 </a:solidFill>
@@ -3499,13 +3458,31 @@
               </a:lnSpc>
             </a:pPr>
             <a:r>
-              <a:rPr sz="1300" b="0">
+              <a:rPr sz="1300" b="0" dirty="0">
                 <a:solidFill>
                   <a:srgbClr val="000000"/>
                 </a:solidFill>
                 <a:latin typeface="Public Sans"/>
               </a:rPr>
-              <a:t>3. Retype the wordmark text in place to create new lockups. Keep tracking tight and use Bold only, per the type guidelines in design.md.</a:t>
+              <a:t>3. Retype the wordmark text in place to create new lockups. Keep tracking tight and use Bold only, per the type guidelines in </a:t>
+            </a:r>
+            <a:r>
+              <a:rPr sz="1300" b="0" dirty="0" err="1">
+                <a:solidFill>
+                  <a:srgbClr val="000000"/>
+                </a:solidFill>
+                <a:latin typeface="Public Sans"/>
+              </a:rPr>
+              <a:t>design.md</a:t>
+            </a:r>
+            <a:r>
+              <a:rPr sz="1300" b="0" dirty="0">
+                <a:solidFill>
+                  <a:srgbClr val="000000"/>
+                </a:solidFill>
+                <a:latin typeface="Public Sans"/>
+              </a:rPr>
+              <a:t>.</a:t>
             </a:r>
           </a:p>
           <a:p>
@@ -3514,15 +3491,12 @@
                 <a:spcPct val="115000"/>
               </a:lnSpc>
             </a:pPr>
-            <a:r>
-              <a:rPr sz="1300" b="0">
-                <a:solidFill>
-                  <a:srgbClr val="000000"/>
-                </a:solidFill>
-                <a:latin typeface="Public Sans"/>
-              </a:rPr>
-              <a:t/>
-            </a:r>
+            <a:endParaRPr sz="1300" b="0" dirty="0">
+              <a:solidFill>
+                <a:srgbClr val="000000"/>
+              </a:solidFill>
+              <a:latin typeface="Public Sans"/>
+            </a:endParaRPr>
           </a:p>
           <a:p>
             <a:pPr algn="l">
@@ -3531,7 +3505,7 @@
               </a:lnSpc>
             </a:pPr>
             <a:r>
-              <a:rPr sz="1300" b="0">
+              <a:rPr sz="1300" b="0" dirty="0">
                 <a:solidFill>
                   <a:srgbClr val="000000"/>
                 </a:solidFill>
@@ -3547,13 +3521,49 @@
               </a:lnSpc>
             </a:pPr>
             <a:r>
-              <a:rPr sz="1300" b="0">
+              <a:rPr sz="1300" b="0" dirty="0">
                 <a:solidFill>
                   <a:srgbClr val="000000"/>
                 </a:solidFill>
                 <a:latin typeface="Public Sans"/>
               </a:rPr>
-              <a:t>NB International Pro CG is not a system font, so PowerPoint will substitute a fallback until it's installed or embedded. Its files are licensed from Neubau under a domain-locked webfont license and are NOT included in this repo — if you have your own licensed copy, install it locally first. Before sharing this file outside a machine that has the font installed:</a:t>
+              <a:t>NB International Pro CG is not a system font, so PowerPoint will substitute a fallback until it's installed or embedded. Its files are licensed from </a:t>
+            </a:r>
+            <a:r>
+              <a:rPr sz="1300" b="0" dirty="0" err="1">
+                <a:solidFill>
+                  <a:srgbClr val="000000"/>
+                </a:solidFill>
+                <a:latin typeface="Public Sans"/>
+              </a:rPr>
+              <a:t>Neubau</a:t>
+            </a:r>
+            <a:r>
+              <a:rPr sz="1300" b="0" dirty="0">
+                <a:solidFill>
+                  <a:srgbClr val="000000"/>
+                </a:solidFill>
+                <a:latin typeface="Public Sans"/>
+              </a:rPr>
+              <a:t> under a domain-locked </a:t>
+            </a:r>
+            <a:r>
+              <a:rPr sz="1300" b="0" dirty="0" err="1">
+                <a:solidFill>
+                  <a:srgbClr val="000000"/>
+                </a:solidFill>
+                <a:latin typeface="Public Sans"/>
+              </a:rPr>
+              <a:t>webfont</a:t>
+            </a:r>
+            <a:r>
+              <a:rPr sz="1300" b="0" dirty="0">
+                <a:solidFill>
+                  <a:srgbClr val="000000"/>
+                </a:solidFill>
+                <a:latin typeface="Public Sans"/>
+              </a:rPr>
+              <a:t> license and are NOT included in this repo — if you have your own licensed copy, install it locally first. Before sharing this file outside a machine that has the font installed:</a:t>
             </a:r>
           </a:p>
           <a:p>
@@ -3563,7 +3573,7 @@
               </a:lnSpc>
             </a:pPr>
             <a:r>
-              <a:rPr sz="1300" b="0">
+              <a:rPr sz="1300" b="0" dirty="0">
                 <a:solidFill>
                   <a:srgbClr val="000000"/>
                 </a:solidFill>
@@ -3579,7 +3589,7 @@
               </a:lnSpc>
             </a:pPr>
             <a:r>
-              <a:rPr sz="1300" b="0">
+              <a:rPr sz="1300" b="0" dirty="0">
                 <a:solidFill>
                   <a:srgbClr val="000000"/>
                 </a:solidFill>
@@ -3599,7 +3609,7 @@
 </file>
 
 <file path=ppt/slides/slide2.xml><?xml version="1.0" encoding="utf-8"?>
-<p:sld xmlns:a="http://schemas.openxmlformats.org/drawingml/2006/main" xmlns:p="http://schemas.openxmlformats.org/presentationml/2006/main" xmlns:r="http://schemas.openxmlformats.org/officeDocument/2006/relationships">
+<p:sld xmlns:a="http://schemas.openxmlformats.org/drawingml/2006/main" xmlns:r="http://schemas.openxmlformats.org/officeDocument/2006/relationships" xmlns:p="http://schemas.openxmlformats.org/presentationml/2006/main">
   <p:cSld>
     <p:spTree>
       <p:nvGrpSpPr>
@@ -3607,50 +3617,14 @@
         <p:cNvGrpSpPr/>
         <p:nvPr/>
       </p:nvGrpSpPr>
-      <p:grpSpPr/>
-      <p:sp>
-        <p:nvSpPr>
-          <p:cNvPr id="2" name="Rectangle 1"/>
-          <p:cNvSpPr/>
-          <p:nvPr/>
-        </p:nvSpPr>
-        <p:spPr>
-          <a:xfrm>
-            <a:off x="0" y="0"/>
-            <a:ext cx="12191695" cy="6858000"/>
-          </a:xfrm>
-          <a:prstGeom prst="rect">
-            <a:avLst/>
-          </a:prstGeom>
-          <a:solidFill>
-            <a:srgbClr val="FFFFFF"/>
-          </a:solidFill>
-          <a:ln>
-            <a:noFill/>
-          </a:ln>
-        </p:spPr>
-        <p:style>
-          <a:lnRef idx="1">
-            <a:schemeClr val="accent1"/>
-          </a:lnRef>
-          <a:fillRef idx="3">
-            <a:schemeClr val="accent1"/>
-          </a:fillRef>
-          <a:effectRef idx="2">
-            <a:schemeClr val="accent1"/>
-          </a:effectRef>
-          <a:fontRef idx="minor">
-            <a:schemeClr val="lt1"/>
-          </a:fontRef>
-        </p:style>
-        <p:txBody>
-          <a:bodyPr rtlCol="0" anchor="ctr"/>
-          <a:lstStyle/>
-          <a:p>
-            <a:pPr algn="ctr"/>
-          </a:p>
-        </p:txBody>
-      </p:sp>
+      <p:grpSpPr>
+        <a:xfrm>
+          <a:off x="0" y="0"/>
+          <a:ext cx="0" cy="0"/>
+          <a:chOff x="0" y="0"/>
+          <a:chExt cx="0" cy="0"/>
+        </a:xfrm>
+      </p:grpSpPr>
       <p:sp>
         <p:nvSpPr>
           <p:cNvPr id="3" name="TextBox 2"/>
@@ -3660,7 +3634,7 @@
         <p:spPr>
           <a:xfrm>
             <a:off x="822960" y="457200"/>
-            <a:ext cx="9144000" cy="548640"/>
+            <a:ext cx="9144000" cy="461665"/>
           </a:xfrm>
           <a:prstGeom prst="rect">
             <a:avLst/>
@@ -3675,609 +3649,248 @@
           <a:p>
             <a:pPr algn="l"/>
             <a:r>
-              <a:rPr sz="2400" b="1">
+              <a:rPr sz="2400" b="1" dirty="0">
                 <a:solidFill>
                   <a:srgbClr val="000000"/>
                 </a:solidFill>
                 <a:latin typeface="NB International Pro CG"/>
               </a:rPr>
-              <a:t>Logo mark</a:t>
-            </a:r>
-          </a:p>
-        </p:txBody>
-      </p:sp>
-      <p:sp>
-        <p:nvSpPr>
-          <p:cNvPr id="4" name="TextBox 3"/>
-          <p:cNvSpPr txBox="1"/>
+              <a:t>Logo</a:t>
+            </a:r>
+            <a:r>
+              <a:rPr lang="en-US" sz="2400" b="1" dirty="0">
+                <a:solidFill>
+                  <a:srgbClr val="000000"/>
+                </a:solidFill>
+                <a:latin typeface="NB International Pro CG"/>
+              </a:rPr>
+              <a:t>s (from SVGs)</a:t>
+            </a:r>
+            <a:endParaRPr sz="2400" b="1" dirty="0">
+              <a:solidFill>
+                <a:srgbClr val="000000"/>
+              </a:solidFill>
+              <a:latin typeface="NB International Pro CG"/>
+            </a:endParaRPr>
+          </a:p>
+        </p:txBody>
+      </p:sp>
+      <p:pic>
+        <p:nvPicPr>
+          <p:cNvPr id="17" name="Graphic 16">
+            <a:extLst>
+              <a:ext uri="{FF2B5EF4-FFF2-40B4-BE49-F238E27FC236}">
+                <a16:creationId xmlns:a16="http://schemas.microsoft.com/office/drawing/2014/main" id="{E6EE3864-CF77-F257-1AE9-8531EE3CE5E5}"/>
+              </a:ext>
+            </a:extLst>
+          </p:cNvPr>
+          <p:cNvPicPr>
+            <a:picLocks noChangeAspect="1"/>
+          </p:cNvPicPr>
           <p:nvPr/>
-        </p:nvSpPr>
+        </p:nvPicPr>
+        <p:blipFill>
+          <a:blip>
+            <a:extLst>
+              <a:ext uri="{96DAC541-7B7A-43D3-8B79-37D633B846F1}">
+                <asvg:svgBlip xmlns:asvg="http://schemas.microsoft.com/office/drawing/2016/SVG/main" r:embed="rId2"/>
+              </a:ext>
+            </a:extLst>
+          </a:blip>
+          <a:stretch>
+            <a:fillRect/>
+          </a:stretch>
+        </p:blipFill>
         <p:spPr>
           <a:xfrm>
-            <a:off x="822960" y="960120"/>
-            <a:ext cx="9144000" cy="457200"/>
+            <a:off x="853440" y="2159616"/>
+            <a:ext cx="2668693" cy="572861"/>
           </a:xfrm>
           <a:prstGeom prst="rect">
             <a:avLst/>
           </a:prstGeom>
-          <a:noFill/>
         </p:spPr>
-        <p:txBody>
-          <a:bodyPr wrap="square" anchor="t">
-            <a:spAutoFit/>
-          </a:bodyPr>
-          <a:lstStyle/>
-          <a:p>
-            <a:pPr algn="l"/>
-            <a:r>
-              <a:rPr sz="1300" b="0">
-                <a:solidFill>
-                  <a:srgbClr val="6F6F6F"/>
-                </a:solidFill>
-                <a:latin typeface="Public Sans"/>
-              </a:rPr>
-              <a:t>Red tile + white glyph, drawn as two native shapes — duplicate this group to start a new mark.</a:t>
-            </a:r>
-          </a:p>
-        </p:txBody>
-      </p:sp>
-      <p:sp>
-        <p:nvSpPr>
-          <p:cNvPr id="5" name="Rectangle 4"/>
-          <p:cNvSpPr/>
+      </p:pic>
+      <p:pic>
+        <p:nvPicPr>
+          <p:cNvPr id="21" name="Graphic 20">
+            <a:extLst>
+              <a:ext uri="{FF2B5EF4-FFF2-40B4-BE49-F238E27FC236}">
+                <a16:creationId xmlns:a16="http://schemas.microsoft.com/office/drawing/2014/main" id="{6130A220-A413-2F47-82DF-F3FE4FA53097}"/>
+              </a:ext>
+            </a:extLst>
+          </p:cNvPr>
+          <p:cNvPicPr>
+            <a:picLocks noChangeAspect="1"/>
+          </p:cNvPicPr>
           <p:nvPr/>
-        </p:nvSpPr>
+        </p:nvPicPr>
+        <p:blipFill>
+          <a:blip>
+            <a:extLst>
+              <a:ext uri="{96DAC541-7B7A-43D3-8B79-37D633B846F1}">
+                <asvg:svgBlip xmlns:asvg="http://schemas.microsoft.com/office/drawing/2016/SVG/main" r:embed="rId3"/>
+              </a:ext>
+            </a:extLst>
+          </a:blip>
+          <a:stretch>
+            <a:fillRect/>
+          </a:stretch>
+        </p:blipFill>
         <p:spPr>
           <a:xfrm>
-            <a:off x="822960" y="1828800"/>
-            <a:ext cx="2011680" cy="1847392"/>
+            <a:off x="853440" y="1443261"/>
+            <a:ext cx="624183" cy="572861"/>
           </a:xfrm>
           <a:prstGeom prst="rect">
             <a:avLst/>
           </a:prstGeom>
-          <a:solidFill>
-            <a:srgbClr val="EF3C24"/>
-          </a:solidFill>
-          <a:ln>
-            <a:noFill/>
-          </a:ln>
         </p:spPr>
-        <p:style>
-          <a:lnRef idx="1">
-            <a:schemeClr val="accent1"/>
-          </a:lnRef>
-          <a:fillRef idx="3">
-            <a:schemeClr val="accent1"/>
-          </a:fillRef>
-          <a:effectRef idx="2">
-            <a:schemeClr val="accent1"/>
-          </a:effectRef>
-          <a:fontRef idx="minor">
-            <a:schemeClr val="lt1"/>
-          </a:fontRef>
-        </p:style>
-        <p:txBody>
-          <a:bodyPr rtlCol="0" anchor="ctr"/>
-          <a:lstStyle/>
-          <a:p>
-            <a:pPr algn="ctr"/>
-          </a:p>
-        </p:txBody>
-      </p:sp>
-      <p:sp>
-        <p:nvSpPr>
-          <p:cNvPr id="6" name="Freeform 5"/>
-          <p:cNvSpPr/>
+      </p:pic>
+      <p:pic>
+        <p:nvPicPr>
+          <p:cNvPr id="23" name="Graphic 22">
+            <a:extLst>
+              <a:ext uri="{FF2B5EF4-FFF2-40B4-BE49-F238E27FC236}">
+                <a16:creationId xmlns:a16="http://schemas.microsoft.com/office/drawing/2014/main" id="{C9AA554A-2BC9-9A81-6153-C01EA8AABBA4}"/>
+              </a:ext>
+            </a:extLst>
+          </p:cNvPr>
+          <p:cNvPicPr>
+            <a:picLocks noChangeAspect="1"/>
+          </p:cNvPicPr>
           <p:nvPr/>
-        </p:nvSpPr>
+        </p:nvPicPr>
+        <p:blipFill>
+          <a:blip>
+            <a:extLst>
+              <a:ext uri="{96DAC541-7B7A-43D3-8B79-37D633B846F1}">
+                <asvg:svgBlip xmlns:asvg="http://schemas.microsoft.com/office/drawing/2016/SVG/main" r:embed="rId4"/>
+              </a:ext>
+            </a:extLst>
+          </a:blip>
+          <a:stretch>
+            <a:fillRect/>
+          </a:stretch>
+        </p:blipFill>
         <p:spPr>
           <a:xfrm>
-            <a:off x="1292352" y="2147316"/>
-            <a:ext cx="1072896" cy="1143304"/>
-          </a:xfrm>
-          <a:custGeom>
-            <a:avLst/>
-            <a:gdLst/>
-            <a:ahLst/>
-            <a:cxnLst/>
-            <a:rect l="l" t="t" r="r" b="b"/>
-            <a:pathLst>
-              <a:path w="320" h="341">
-                <a:moveTo>
-                  <a:pt x="0" y="259"/>
-                </a:moveTo>
-                <a:lnTo>
-                  <a:pt x="0" y="200"/>
-                </a:lnTo>
-                <a:lnTo>
-                  <a:pt x="249" y="130"/>
-                </a:lnTo>
-                <a:lnTo>
-                  <a:pt x="0" y="59"/>
-                </a:lnTo>
-                <a:lnTo>
-                  <a:pt x="0" y="0"/>
-                </a:lnTo>
-                <a:lnTo>
-                  <a:pt x="320" y="98"/>
-                </a:lnTo>
-                <a:lnTo>
-                  <a:pt x="320" y="162"/>
-                </a:lnTo>
-                <a:close/>
-                <a:moveTo>
-                  <a:pt x="0" y="341"/>
-                </a:moveTo>
-                <a:lnTo>
-                  <a:pt x="0" y="288"/>
-                </a:lnTo>
-                <a:lnTo>
-                  <a:pt x="320" y="288"/>
-                </a:lnTo>
-                <a:lnTo>
-                  <a:pt x="320" y="341"/>
-                </a:lnTo>
-                <a:close/>
-              </a:path>
-            </a:pathLst>
-          </a:custGeom>
-          <a:solidFill>
-            <a:srgbClr val="FFFFFF"/>
-          </a:solidFill>
-          <a:ln>
-            <a:noFill/>
-          </a:ln>
-        </p:spPr>
-        <p:style>
-          <a:lnRef idx="1">
-            <a:schemeClr val="accent1"/>
-          </a:lnRef>
-          <a:fillRef idx="3">
-            <a:schemeClr val="accent1"/>
-          </a:fillRef>
-          <a:effectRef idx="2">
-            <a:schemeClr val="accent1"/>
-          </a:effectRef>
-          <a:fontRef idx="minor">
-            <a:schemeClr val="lt1"/>
-          </a:fontRef>
-        </p:style>
-        <p:txBody>
-          <a:bodyPr rtlCol="0" anchor="ctr"/>
-          <a:lstStyle/>
-          <a:p>
-            <a:pPr algn="ctr"/>
-          </a:p>
-        </p:txBody>
-      </p:sp>
-      <p:sp>
-        <p:nvSpPr>
-          <p:cNvPr id="7" name="Rectangle 6"/>
-          <p:cNvSpPr/>
-          <p:nvPr/>
-        </p:nvSpPr>
-        <p:spPr>
-          <a:xfrm>
-            <a:off x="3383280" y="1828800"/>
-            <a:ext cx="1280160" cy="1175613"/>
+            <a:off x="853440" y="2875971"/>
+            <a:ext cx="4582886" cy="572861"/>
           </a:xfrm>
           <a:prstGeom prst="rect">
             <a:avLst/>
           </a:prstGeom>
-          <a:solidFill>
-            <a:srgbClr val="EF3C24"/>
-          </a:solidFill>
-          <a:ln>
-            <a:noFill/>
-          </a:ln>
         </p:spPr>
-        <p:style>
-          <a:lnRef idx="1">
-            <a:schemeClr val="accent1"/>
-          </a:lnRef>
-          <a:fillRef idx="3">
-            <a:schemeClr val="accent1"/>
-          </a:fillRef>
-          <a:effectRef idx="2">
-            <a:schemeClr val="accent1"/>
-          </a:effectRef>
-          <a:fontRef idx="minor">
-            <a:schemeClr val="lt1"/>
-          </a:fontRef>
-        </p:style>
-        <p:txBody>
-          <a:bodyPr rtlCol="0" anchor="ctr"/>
-          <a:lstStyle/>
-          <a:p>
-            <a:pPr algn="ctr"/>
-          </a:p>
-        </p:txBody>
-      </p:sp>
-      <p:sp>
-        <p:nvSpPr>
-          <p:cNvPr id="8" name="Freeform 7"/>
-          <p:cNvSpPr/>
+      </p:pic>
+      <p:pic>
+        <p:nvPicPr>
+          <p:cNvPr id="25" name="Graphic 24">
+            <a:extLst>
+              <a:ext uri="{FF2B5EF4-FFF2-40B4-BE49-F238E27FC236}">
+                <a16:creationId xmlns:a16="http://schemas.microsoft.com/office/drawing/2014/main" id="{6CECCC3B-F2DF-D4DD-BD58-F6C411C1C988}"/>
+              </a:ext>
+            </a:extLst>
+          </p:cNvPr>
+          <p:cNvPicPr>
+            <a:picLocks noChangeAspect="1"/>
+          </p:cNvPicPr>
           <p:nvPr/>
-        </p:nvSpPr>
+        </p:nvPicPr>
+        <p:blipFill>
+          <a:blip>
+            <a:extLst>
+              <a:ext uri="{96DAC541-7B7A-43D3-8B79-37D633B846F1}">
+                <asvg:svgBlip xmlns:asvg="http://schemas.microsoft.com/office/drawing/2016/SVG/main" r:embed="rId5"/>
+              </a:ext>
+            </a:extLst>
+          </a:blip>
+          <a:stretch>
+            <a:fillRect/>
+          </a:stretch>
+        </p:blipFill>
         <p:spPr>
           <a:xfrm>
-            <a:off x="3681984" y="2031492"/>
-            <a:ext cx="682752" cy="727557"/>
-          </a:xfrm>
-          <a:custGeom>
-            <a:avLst/>
-            <a:gdLst/>
-            <a:ahLst/>
-            <a:cxnLst/>
-            <a:rect l="l" t="t" r="r" b="b"/>
-            <a:pathLst>
-              <a:path w="320" h="341">
-                <a:moveTo>
-                  <a:pt x="0" y="259"/>
-                </a:moveTo>
-                <a:lnTo>
-                  <a:pt x="0" y="200"/>
-                </a:lnTo>
-                <a:lnTo>
-                  <a:pt x="249" y="130"/>
-                </a:lnTo>
-                <a:lnTo>
-                  <a:pt x="0" y="59"/>
-                </a:lnTo>
-                <a:lnTo>
-                  <a:pt x="0" y="0"/>
-                </a:lnTo>
-                <a:lnTo>
-                  <a:pt x="320" y="98"/>
-                </a:lnTo>
-                <a:lnTo>
-                  <a:pt x="320" y="162"/>
-                </a:lnTo>
-                <a:close/>
-                <a:moveTo>
-                  <a:pt x="0" y="341"/>
-                </a:moveTo>
-                <a:lnTo>
-                  <a:pt x="0" y="288"/>
-                </a:lnTo>
-                <a:lnTo>
-                  <a:pt x="320" y="288"/>
-                </a:lnTo>
-                <a:lnTo>
-                  <a:pt x="320" y="341"/>
-                </a:lnTo>
-                <a:close/>
-              </a:path>
-            </a:pathLst>
-          </a:custGeom>
-          <a:solidFill>
-            <a:srgbClr val="FFFFFF"/>
-          </a:solidFill>
-          <a:ln>
-            <a:noFill/>
-          </a:ln>
-        </p:spPr>
-        <p:style>
-          <a:lnRef idx="1">
-            <a:schemeClr val="accent1"/>
-          </a:lnRef>
-          <a:fillRef idx="3">
-            <a:schemeClr val="accent1"/>
-          </a:fillRef>
-          <a:effectRef idx="2">
-            <a:schemeClr val="accent1"/>
-          </a:effectRef>
-          <a:fontRef idx="minor">
-            <a:schemeClr val="lt1"/>
-          </a:fontRef>
-        </p:style>
-        <p:txBody>
-          <a:bodyPr rtlCol="0" anchor="ctr"/>
-          <a:lstStyle/>
-          <a:p>
-            <a:pPr algn="ctr"/>
-          </a:p>
-        </p:txBody>
-      </p:sp>
-      <p:sp>
-        <p:nvSpPr>
-          <p:cNvPr id="9" name="Rectangle 8"/>
-          <p:cNvSpPr/>
-          <p:nvPr/>
-        </p:nvSpPr>
-        <p:spPr>
-          <a:xfrm>
-            <a:off x="5212080" y="1828800"/>
-            <a:ext cx="822960" cy="755751"/>
+            <a:off x="853440" y="3592326"/>
+            <a:ext cx="2668693" cy="845635"/>
           </a:xfrm>
           <a:prstGeom prst="rect">
             <a:avLst/>
           </a:prstGeom>
-          <a:solidFill>
-            <a:srgbClr val="EF3C24"/>
-          </a:solidFill>
-          <a:ln>
-            <a:noFill/>
-          </a:ln>
         </p:spPr>
-        <p:style>
-          <a:lnRef idx="1">
-            <a:schemeClr val="accent1"/>
-          </a:lnRef>
-          <a:fillRef idx="3">
-            <a:schemeClr val="accent1"/>
-          </a:fillRef>
-          <a:effectRef idx="2">
-            <a:schemeClr val="accent1"/>
-          </a:effectRef>
-          <a:fontRef idx="minor">
-            <a:schemeClr val="lt1"/>
-          </a:fontRef>
-        </p:style>
-        <p:txBody>
-          <a:bodyPr rtlCol="0" anchor="ctr"/>
-          <a:lstStyle/>
-          <a:p>
-            <a:pPr algn="ctr"/>
-          </a:p>
-        </p:txBody>
-      </p:sp>
-      <p:sp>
-        <p:nvSpPr>
-          <p:cNvPr id="10" name="Freeform 9"/>
-          <p:cNvSpPr/>
+      </p:pic>
+      <p:pic>
+        <p:nvPicPr>
+          <p:cNvPr id="5" name="Graphic 4">
+            <a:extLst>
+              <a:ext uri="{FF2B5EF4-FFF2-40B4-BE49-F238E27FC236}">
+                <a16:creationId xmlns:a16="http://schemas.microsoft.com/office/drawing/2014/main" id="{A754C05B-366C-965E-BFDD-2DEB6AC2BED7}"/>
+              </a:ext>
+            </a:extLst>
+          </p:cNvPr>
+          <p:cNvPicPr>
+            <a:picLocks noChangeAspect="1"/>
+          </p:cNvPicPr>
           <p:nvPr/>
-        </p:nvSpPr>
+        </p:nvPicPr>
+        <p:blipFill>
+          <a:blip>
+            <a:extLst>
+              <a:ext uri="{96DAC541-7B7A-43D3-8B79-37D633B846F1}">
+                <asvg:svgBlip xmlns:asvg="http://schemas.microsoft.com/office/drawing/2016/SVG/main" r:embed="rId2"/>
+              </a:ext>
+            </a:extLst>
+          </a:blip>
+          <a:stretch>
+            <a:fillRect/>
+          </a:stretch>
+        </p:blipFill>
         <p:spPr>
           <a:xfrm>
-            <a:off x="5404104" y="1959102"/>
-            <a:ext cx="438912" cy="467715"/>
-          </a:xfrm>
-          <a:custGeom>
-            <a:avLst/>
-            <a:gdLst/>
-            <a:ahLst/>
-            <a:cxnLst/>
-            <a:rect l="l" t="t" r="r" b="b"/>
-            <a:pathLst>
-              <a:path w="320" h="341">
-                <a:moveTo>
-                  <a:pt x="0" y="259"/>
-                </a:moveTo>
-                <a:lnTo>
-                  <a:pt x="0" y="200"/>
-                </a:lnTo>
-                <a:lnTo>
-                  <a:pt x="249" y="130"/>
-                </a:lnTo>
-                <a:lnTo>
-                  <a:pt x="0" y="59"/>
-                </a:lnTo>
-                <a:lnTo>
-                  <a:pt x="0" y="0"/>
-                </a:lnTo>
-                <a:lnTo>
-                  <a:pt x="320" y="98"/>
-                </a:lnTo>
-                <a:lnTo>
-                  <a:pt x="320" y="162"/>
-                </a:lnTo>
-                <a:close/>
-                <a:moveTo>
-                  <a:pt x="0" y="341"/>
-                </a:moveTo>
-                <a:lnTo>
-                  <a:pt x="0" y="288"/>
-                </a:lnTo>
-                <a:lnTo>
-                  <a:pt x="320" y="288"/>
-                </a:lnTo>
-                <a:lnTo>
-                  <a:pt x="320" y="341"/>
-                </a:lnTo>
-                <a:close/>
-              </a:path>
-            </a:pathLst>
-          </a:custGeom>
-          <a:solidFill>
-            <a:srgbClr val="FFFFFF"/>
-          </a:solidFill>
-          <a:ln>
-            <a:noFill/>
-          </a:ln>
-        </p:spPr>
-        <p:style>
-          <a:lnRef idx="1">
-            <a:schemeClr val="accent1"/>
-          </a:lnRef>
-          <a:fillRef idx="3">
-            <a:schemeClr val="accent1"/>
-          </a:fillRef>
-          <a:effectRef idx="2">
-            <a:schemeClr val="accent1"/>
-          </a:effectRef>
-          <a:fontRef idx="minor">
-            <a:schemeClr val="lt1"/>
-          </a:fontRef>
-        </p:style>
-        <p:txBody>
-          <a:bodyPr rtlCol="0" anchor="ctr"/>
-          <a:lstStyle/>
-          <a:p>
-            <a:pPr algn="ctr"/>
-          </a:p>
-        </p:txBody>
-      </p:sp>
-      <p:sp>
-        <p:nvSpPr>
-          <p:cNvPr id="11" name="Rectangle 10"/>
-          <p:cNvSpPr/>
-          <p:nvPr/>
-        </p:nvSpPr>
-        <p:spPr>
-          <a:xfrm>
-            <a:off x="8595360" y="1828800"/>
-            <a:ext cx="2011680" cy="1847392"/>
+            <a:off x="853440" y="4683741"/>
+            <a:ext cx="2668693" cy="572861"/>
           </a:xfrm>
           <a:prstGeom prst="rect">
             <a:avLst/>
           </a:prstGeom>
-          <a:solidFill>
-            <a:srgbClr val="FFFFFF"/>
-          </a:solidFill>
-          <a:ln w="12700">
-            <a:solidFill>
-              <a:srgbClr val="F7F7F7"/>
-            </a:solidFill>
-          </a:ln>
         </p:spPr>
-        <p:style>
-          <a:lnRef idx="1">
-            <a:schemeClr val="accent1"/>
-          </a:lnRef>
-          <a:fillRef idx="3">
-            <a:schemeClr val="accent1"/>
-          </a:fillRef>
-          <a:effectRef idx="2">
-            <a:schemeClr val="accent1"/>
-          </a:effectRef>
-          <a:fontRef idx="minor">
-            <a:schemeClr val="lt1"/>
-          </a:fontRef>
-        </p:style>
-        <p:txBody>
-          <a:bodyPr rtlCol="0" anchor="ctr"/>
-          <a:lstStyle/>
-          <a:p>
-            <a:pPr algn="ctr"/>
-          </a:p>
-        </p:txBody>
-      </p:sp>
-      <p:sp>
-        <p:nvSpPr>
-          <p:cNvPr id="13" name="Freeform 12"/>
-          <p:cNvSpPr/>
+      </p:pic>
+      <p:pic>
+        <p:nvPicPr>
+          <p:cNvPr id="6" name="Graphic 5">
+            <a:extLst>
+              <a:ext uri="{FF2B5EF4-FFF2-40B4-BE49-F238E27FC236}">
+                <a16:creationId xmlns:a16="http://schemas.microsoft.com/office/drawing/2014/main" id="{76FD7860-DF08-7CFE-6266-9DC7C49BF2A0}"/>
+              </a:ext>
+            </a:extLst>
+          </p:cNvPr>
+          <p:cNvPicPr>
+            <a:picLocks noChangeAspect="1"/>
+          </p:cNvPicPr>
           <p:nvPr/>
-        </p:nvSpPr>
+        </p:nvPicPr>
+        <p:blipFill>
+          <a:blip>
+            <a:extLst>
+              <a:ext uri="{96DAC541-7B7A-43D3-8B79-37D633B846F1}">
+                <asvg:svgBlip xmlns:asvg="http://schemas.microsoft.com/office/drawing/2016/SVG/main" r:embed="rId3"/>
+              </a:ext>
+            </a:extLst>
+          </a:blip>
+          <a:stretch>
+            <a:fillRect/>
+          </a:stretch>
+        </p:blipFill>
         <p:spPr>
           <a:xfrm>
-            <a:off x="9064752" y="2147316"/>
-            <a:ext cx="1072896" cy="1143304"/>
-          </a:xfrm>
-          <a:custGeom>
-            <a:avLst/>
-            <a:gdLst/>
-            <a:ahLst/>
-            <a:cxnLst/>
-            <a:rect l="l" t="t" r="r" b="b"/>
-            <a:pathLst>
-              <a:path w="320" h="341">
-                <a:moveTo>
-                  <a:pt x="0" y="259"/>
-                </a:moveTo>
-                <a:lnTo>
-                  <a:pt x="0" y="200"/>
-                </a:lnTo>
-                <a:lnTo>
-                  <a:pt x="249" y="130"/>
-                </a:lnTo>
-                <a:lnTo>
-                  <a:pt x="0" y="59"/>
-                </a:lnTo>
-                <a:lnTo>
-                  <a:pt x="0" y="0"/>
-                </a:lnTo>
-                <a:lnTo>
-                  <a:pt x="320" y="98"/>
-                </a:lnTo>
-                <a:lnTo>
-                  <a:pt x="320" y="162"/>
-                </a:lnTo>
-                <a:close/>
-                <a:moveTo>
-                  <a:pt x="0" y="341"/>
-                </a:moveTo>
-                <a:lnTo>
-                  <a:pt x="0" y="288"/>
-                </a:lnTo>
-                <a:lnTo>
-                  <a:pt x="320" y="288"/>
-                </a:lnTo>
-                <a:lnTo>
-                  <a:pt x="320" y="341"/>
-                </a:lnTo>
-                <a:close/>
-              </a:path>
-            </a:pathLst>
-          </a:custGeom>
-          <a:solidFill>
-            <a:srgbClr val="EF3C24"/>
-          </a:solidFill>
-          <a:ln>
-            <a:noFill/>
-          </a:ln>
-        </p:spPr>
-        <p:style>
-          <a:lnRef idx="1">
-            <a:schemeClr val="accent1"/>
-          </a:lnRef>
-          <a:fillRef idx="3">
-            <a:schemeClr val="accent1"/>
-          </a:fillRef>
-          <a:effectRef idx="2">
-            <a:schemeClr val="accent1"/>
-          </a:effectRef>
-          <a:fontRef idx="minor">
-            <a:schemeClr val="lt1"/>
-          </a:fontRef>
-        </p:style>
-        <p:txBody>
-          <a:bodyPr rtlCol="0" anchor="ctr"/>
-          <a:lstStyle/>
-          <a:p>
-            <a:pPr algn="ctr"/>
-          </a:p>
-        </p:txBody>
-      </p:sp>
-      <p:sp>
-        <p:nvSpPr>
-          <p:cNvPr id="14" name="TextBox 13"/>
-          <p:cNvSpPr txBox="1"/>
-          <p:nvPr/>
-        </p:nvSpPr>
-        <p:spPr>
-          <a:xfrm>
-            <a:off x="822960" y="4572000"/>
-            <a:ext cx="10515600" cy="1645920"/>
+            <a:off x="853440" y="5415186"/>
+            <a:ext cx="624183" cy="572861"/>
           </a:xfrm>
           <a:prstGeom prst="rect">
             <a:avLst/>
           </a:prstGeom>
-          <a:noFill/>
         </p:spPr>
-        <p:txBody>
-          <a:bodyPr wrap="square" anchor="t">
-            <a:spAutoFit/>
-          </a:bodyPr>
-          <a:lstStyle/>
-          <a:p>
-            <a:pPr algn="l">
-              <a:lnSpc>
-                <a:spcPct val="115000"/>
-              </a:lnSpc>
-            </a:pPr>
-            <a:r>
-              <a:rPr sz="1300" b="0">
-                <a:solidFill>
-                  <a:srgbClr val="6F6F6F"/>
-                </a:solidFill>
-                <a:latin typeface="Public Sans"/>
-              </a:rPr>
-              <a:t>Only ever place the glyph on the brand red tile or, as shown at right, in solid red on a light neutral surface. Never redraw the chevron/bar proportions or place the glyph on photography.</a:t>
-            </a:r>
-          </a:p>
-        </p:txBody>
-      </p:sp>
+      </p:pic>
     </p:spTree>
   </p:cSld>
   <p:clrMapOvr>
@@ -4287,7 +3900,7 @@
 </file>
 
 <file path=ppt/slides/slide3.xml><?xml version="1.0" encoding="utf-8"?>
-<p:sld xmlns:a="http://schemas.openxmlformats.org/drawingml/2006/main" xmlns:p="http://schemas.openxmlformats.org/presentationml/2006/main" xmlns:r="http://schemas.openxmlformats.org/officeDocument/2006/relationships">
+<p:sld xmlns:a="http://schemas.openxmlformats.org/drawingml/2006/main" xmlns:r="http://schemas.openxmlformats.org/officeDocument/2006/relationships" xmlns:p="http://schemas.openxmlformats.org/presentationml/2006/main">
   <p:cSld>
     <p:spTree>
       <p:nvGrpSpPr>
@@ -4295,60 +3908,24 @@
         <p:cNvGrpSpPr/>
         <p:nvPr/>
       </p:nvGrpSpPr>
-      <p:grpSpPr/>
-      <p:sp>
-        <p:nvSpPr>
-          <p:cNvPr id="2" name="Rectangle 1"/>
-          <p:cNvSpPr/>
-          <p:nvPr/>
-        </p:nvSpPr>
-        <p:spPr>
-          <a:xfrm>
-            <a:off x="0" y="0"/>
-            <a:ext cx="12191695" cy="6858000"/>
-          </a:xfrm>
-          <a:prstGeom prst="rect">
-            <a:avLst/>
-          </a:prstGeom>
-          <a:solidFill>
-            <a:srgbClr val="FFFFFF"/>
-          </a:solidFill>
-          <a:ln>
-            <a:noFill/>
-          </a:ln>
-        </p:spPr>
-        <p:style>
-          <a:lnRef idx="1">
-            <a:schemeClr val="accent1"/>
-          </a:lnRef>
-          <a:fillRef idx="3">
-            <a:schemeClr val="accent1"/>
-          </a:fillRef>
-          <a:effectRef idx="2">
-            <a:schemeClr val="accent1"/>
-          </a:effectRef>
-          <a:fontRef idx="minor">
-            <a:schemeClr val="lt1"/>
-          </a:fontRef>
-        </p:style>
-        <p:txBody>
-          <a:bodyPr rtlCol="0" anchor="ctr"/>
-          <a:lstStyle/>
-          <a:p>
-            <a:pPr algn="ctr"/>
-          </a:p>
-        </p:txBody>
-      </p:sp>
-      <p:sp>
-        <p:nvSpPr>
-          <p:cNvPr id="3" name="TextBox 2"/>
+      <p:grpSpPr>
+        <a:xfrm>
+          <a:off x="0" y="0"/>
+          <a:ext cx="0" cy="0"/>
+          <a:chOff x="0" y="0"/>
+          <a:chExt cx="0" cy="0"/>
+        </a:xfrm>
+      </p:grpSpPr>
+      <p:sp>
+        <p:nvSpPr>
+          <p:cNvPr id="2" name="TextBox 1"/>
           <p:cNvSpPr txBox="1"/>
           <p:nvPr/>
         </p:nvSpPr>
         <p:spPr>
           <a:xfrm>
             <a:off x="822960" y="457200"/>
-            <a:ext cx="9144000" cy="548640"/>
+            <a:ext cx="10515600" cy="502920"/>
           </a:xfrm>
           <a:prstGeom prst="rect">
             <a:avLst/>
@@ -4356,12 +3933,11 @@
           <a:noFill/>
         </p:spPr>
         <p:txBody>
-          <a:bodyPr wrap="square" anchor="t">
+          <a:bodyPr wrap="none" lIns="0" rIns="0" tIns="0" bIns="0">
             <a:spAutoFit/>
           </a:bodyPr>
           <a:lstStyle/>
           <a:p>
-            <a:pPr algn="l"/>
             <a:r>
               <a:rPr sz="2400" b="1">
                 <a:solidFill>
@@ -4369,21 +3945,21 @@
                 </a:solidFill>
                 <a:latin typeface="NB International Pro CG"/>
               </a:rPr>
-              <a:t>Wordmark — live text</a:t>
-            </a:r>
-          </a:p>
-        </p:txBody>
-      </p:sp>
-      <p:sp>
-        <p:nvSpPr>
-          <p:cNvPr id="4" name="TextBox 3"/>
+              <a:t>Type — fonts &amp; sizes</a:t>
+            </a:r>
+          </a:p>
+        </p:txBody>
+      </p:sp>
+      <p:sp>
+        <p:nvSpPr>
+          <p:cNvPr id="3" name="TextBox 2"/>
           <p:cNvSpPr txBox="1"/>
           <p:nvPr/>
         </p:nvSpPr>
         <p:spPr>
           <a:xfrm>
-            <a:off x="822960" y="960120"/>
-            <a:ext cx="9144000" cy="457200"/>
+            <a:off x="822960" y="1024128"/>
+            <a:ext cx="5074920" cy="5577840"/>
           </a:xfrm>
           <a:prstGeom prst="rect">
             <a:avLst/>
@@ -4391,34 +3967,227 @@
           <a:noFill/>
         </p:spPr>
         <p:txBody>
-          <a:bodyPr wrap="square" anchor="t">
+          <a:bodyPr wrap="square" lIns="0" rIns="0" tIns="0" bIns="0">
             <a:spAutoFit/>
           </a:bodyPr>
           <a:lstStyle/>
           <a:p>
-            <a:pPr algn="l"/>
-            <a:r>
-              <a:rPr sz="1300" b="0">
-                <a:solidFill>
-                  <a:srgbClr val="6F6F6F"/>
+            <a:pPr>
+              <a:lnSpc>
+                <a:spcPct val="100000"/>
+              </a:lnSpc>
+              <a:spcBef>
+                <a:spcPts val="0"/>
+              </a:spcBef>
+              <a:spcAft>
+                <a:spcPts val="200"/>
+              </a:spcAft>
+            </a:pPr>
+            <a:r>
+              <a:rPr sz="3400" b="1">
+                <a:solidFill>
+                  <a:srgbClr val="EF3C24"/>
+                </a:solidFill>
+                <a:latin typeface="NB International Pro CG"/>
+              </a:rPr>
+              <a:t>public ai</a:t>
+            </a:r>
+          </a:p>
+          <a:p>
+            <a:pPr>
+              <a:spcBef>
+                <a:spcPts val="0"/>
+              </a:spcBef>
+              <a:spcAft>
+                <a:spcPts val="1200"/>
+              </a:spcAft>
+            </a:pPr>
+            <a:r>
+              <a:rPr sz="800">
+                <a:solidFill>
+                  <a:srgbClr val="000000"/>
+                </a:solidFill>
+                <a:latin typeface="Overpass Mono"/>
+              </a:rPr>
+              <a:t>NB International Pro CG Bold · 90px · brand wordmarks &amp; statements</a:t>
+            </a:r>
+          </a:p>
+          <a:p>
+            <a:pPr>
+              <a:lnSpc>
+                <a:spcPct val="100000"/>
+              </a:lnSpc>
+              <a:spcBef>
+                <a:spcPts val="0"/>
+              </a:spcBef>
+              <a:spcAft>
+                <a:spcPts val="200"/>
+              </a:spcAft>
+            </a:pPr>
+            <a:r>
+              <a:rPr sz="1900" b="1">
+                <a:solidFill>
+                  <a:srgbClr val="000000"/>
+                </a:solidFill>
+                <a:latin typeface="Overpass"/>
+              </a:rPr>
+              <a:t>What if AI were public infrastructure?</a:t>
+            </a:r>
+          </a:p>
+          <a:p>
+            <a:pPr>
+              <a:spcBef>
+                <a:spcPts val="0"/>
+              </a:spcBef>
+              <a:spcAft>
+                <a:spcPts val="1200"/>
+              </a:spcAft>
+            </a:pPr>
+            <a:r>
+              <a:rPr sz="800">
+                <a:solidFill>
+                  <a:srgbClr val="000000"/>
+                </a:solidFill>
+                <a:latin typeface="Overpass Mono"/>
+              </a:rPr>
+              <a:t>Overpass Bold · 38px · headlines (--font-headline; NB fallback in --font-brand)</a:t>
+            </a:r>
+          </a:p>
+          <a:p>
+            <a:pPr>
+              <a:lnSpc>
+                <a:spcPct val="100000"/>
+              </a:lnSpc>
+              <a:spcBef>
+                <a:spcPts val="0"/>
+              </a:spcBef>
+              <a:spcAft>
+                <a:spcPts val="200"/>
+              </a:spcAft>
+            </a:pPr>
+            <a:r>
+              <a:rPr sz="3800">
+                <a:solidFill>
+                  <a:srgbClr val="000000"/>
+                </a:solidFill>
+                <a:latin typeface="Public Sans Light"/>
+              </a:rPr>
+              <a:t>Try Apertus</a:t>
+            </a:r>
+          </a:p>
+          <a:p>
+            <a:pPr>
+              <a:spcBef>
+                <a:spcPts val="0"/>
+              </a:spcBef>
+              <a:spcAft>
+                <a:spcPts val="1200"/>
+              </a:spcAft>
+            </a:pPr>
+            <a:r>
+              <a:rPr sz="800">
+                <a:solidFill>
+                  <a:srgbClr val="000000"/>
+                </a:solidFill>
+                <a:latin typeface="Overpass Mono"/>
+              </a:rPr>
+              <a:t>Public Sans Light · 140px · hero display · lh 0.9 · ls −5%</a:t>
+            </a:r>
+          </a:p>
+          <a:p>
+            <a:pPr>
+              <a:lnSpc>
+                <a:spcPct val="100000"/>
+              </a:lnSpc>
+              <a:spcBef>
+                <a:spcPts val="0"/>
+              </a:spcBef>
+              <a:spcAft>
+                <a:spcPts val="200"/>
+              </a:spcAft>
+            </a:pPr>
+            <a:r>
+              <a:rPr sz="2100">
+                <a:solidFill>
+                  <a:srgbClr val="000000"/>
+                </a:solidFill>
+                <a:latin typeface="Public Sans Light"/>
+              </a:rPr>
+              <a:t>By the people, for the people</a:t>
+            </a:r>
+          </a:p>
+          <a:p>
+            <a:pPr>
+              <a:spcBef>
+                <a:spcPts val="0"/>
+              </a:spcBef>
+              <a:spcAft>
+                <a:spcPts val="1200"/>
+              </a:spcAft>
+            </a:pPr>
+            <a:r>
+              <a:rPr sz="800">
+                <a:solidFill>
+                  <a:srgbClr val="000000"/>
+                </a:solidFill>
+                <a:latin typeface="Overpass Mono"/>
+              </a:rPr>
+              <a:t>Public Sans Light · 60px · section display · lh 0.9 · ls −3%</a:t>
+            </a:r>
+          </a:p>
+          <a:p>
+            <a:pPr>
+              <a:lnSpc>
+                <a:spcPct val="100000"/>
+              </a:lnSpc>
+              <a:spcBef>
+                <a:spcPts val="0"/>
+              </a:spcBef>
+              <a:spcAft>
+                <a:spcPts val="200"/>
+              </a:spcAft>
+            </a:pPr>
+            <a:r>
+              <a:rPr sz="1700">
+                <a:solidFill>
+                  <a:srgbClr val="000000"/>
                 </a:solidFill>
                 <a:latin typeface="Public Sans"/>
               </a:rPr>
-              <a:t>Set in NB International Pro CG Bold — retype this text box to create a new lockup.</a:t>
-            </a:r>
-          </a:p>
-        </p:txBody>
-      </p:sp>
-      <p:sp>
-        <p:nvSpPr>
-          <p:cNvPr id="5" name="TextBox 4"/>
+              <a:t>Public AI</a:t>
+            </a:r>
+          </a:p>
+          <a:p>
+            <a:pPr>
+              <a:spcBef>
+                <a:spcPts val="0"/>
+              </a:spcBef>
+              <a:spcAft>
+                <a:spcPts val="600"/>
+              </a:spcAft>
+            </a:pPr>
+            <a:r>
+              <a:rPr sz="800">
+                <a:solidFill>
+                  <a:srgbClr val="000000"/>
+                </a:solidFill>
+                <a:latin typeface="Overpass Mono"/>
+              </a:rPr>
+              <a:t>Public Sans · 30px · navigation wordmark · ls −3%</a:t>
+            </a:r>
+          </a:p>
+        </p:txBody>
+      </p:sp>
+      <p:sp>
+        <p:nvSpPr>
+          <p:cNvPr id="4" name="TextBox 3"/>
           <p:cNvSpPr txBox="1"/>
           <p:nvPr/>
         </p:nvSpPr>
         <p:spPr>
           <a:xfrm>
-            <a:off x="822960" y="1737360"/>
-            <a:ext cx="8229600" cy="1280160"/>
+            <a:off x="6263640" y="1024128"/>
+            <a:ext cx="5074920" cy="5577840"/>
           </a:xfrm>
           <a:prstGeom prst="rect">
             <a:avLst/>
@@ -4426,267 +4195,264 @@
           <a:noFill/>
         </p:spPr>
         <p:txBody>
-          <a:bodyPr wrap="square" anchor="t">
+          <a:bodyPr wrap="square" lIns="0" rIns="0" tIns="0" bIns="0">
             <a:spAutoFit/>
           </a:bodyPr>
           <a:lstStyle/>
           <a:p>
-            <a:pPr algn="l"/>
-            <a:r>
-              <a:rPr sz="6000" b="1">
-                <a:solidFill>
-                  <a:srgbClr val="EF3C24"/>
-                </a:solidFill>
-                <a:latin typeface="NB International Pro CG"/>
+            <a:pPr>
+              <a:lnSpc>
+                <a:spcPct val="100000"/>
+              </a:lnSpc>
+              <a:spcBef>
+                <a:spcPts val="0"/>
+              </a:spcBef>
+              <a:spcAft>
+                <a:spcPts val="200"/>
+              </a:spcAft>
+            </a:pPr>
+            <a:r>
+              <a:rPr sz="1500" b="1">
+                <a:solidFill>
+                  <a:srgbClr val="000000"/>
+                </a:solidFill>
+                <a:latin typeface="Inter Semi Bold"/>
               </a:rPr>
-              <a:t>Public AI</a:t>
-            </a:r>
-          </a:p>
-        </p:txBody>
-      </p:sp>
-      <p:sp>
-        <p:nvSpPr>
-          <p:cNvPr id="6" name="Rectangle 5"/>
-          <p:cNvSpPr/>
-          <p:nvPr/>
-        </p:nvSpPr>
-        <p:spPr>
-          <a:xfrm>
-            <a:off x="822960" y="3200400"/>
-            <a:ext cx="10515600" cy="12700"/>
-          </a:xfrm>
-          <a:prstGeom prst="rect">
-            <a:avLst/>
-          </a:prstGeom>
-          <a:solidFill>
-            <a:srgbClr val="F7F7F7"/>
-          </a:solidFill>
-          <a:ln>
-            <a:noFill/>
-          </a:ln>
-        </p:spPr>
-        <p:style>
-          <a:lnRef idx="1">
-            <a:schemeClr val="accent1"/>
-          </a:lnRef>
-          <a:fillRef idx="3">
-            <a:schemeClr val="accent1"/>
-          </a:fillRef>
-          <a:effectRef idx="2">
-            <a:schemeClr val="accent1"/>
-          </a:effectRef>
-          <a:fontRef idx="minor">
-            <a:schemeClr val="lt1"/>
-          </a:fontRef>
-        </p:style>
-        <p:txBody>
-          <a:bodyPr rtlCol="0" anchor="ctr"/>
-          <a:lstStyle/>
-          <a:p>
-            <a:pPr algn="ctr"/>
-          </a:p>
-        </p:txBody>
-      </p:sp>
-      <p:sp>
-        <p:nvSpPr>
-          <p:cNvPr id="7" name="TextBox 6"/>
-          <p:cNvSpPr txBox="1"/>
-          <p:nvPr/>
-        </p:nvSpPr>
-        <p:spPr>
-          <a:xfrm>
-            <a:off x="822960" y="3429000"/>
-            <a:ext cx="9144000" cy="457200"/>
-          </a:xfrm>
-          <a:prstGeom prst="rect">
-            <a:avLst/>
-          </a:prstGeom>
-          <a:noFill/>
-        </p:spPr>
-        <p:txBody>
-          <a:bodyPr wrap="square" anchor="t">
-            <a:spAutoFit/>
-          </a:bodyPr>
-          <a:lstStyle/>
-          <a:p>
-            <a:pPr algn="l"/>
-            <a:r>
-              <a:rPr sz="1300" b="0">
-                <a:solidFill>
-                  <a:srgbClr val="6F6F6F"/>
+              <a:t>With love, from Switzerland</a:t>
+            </a:r>
+          </a:p>
+          <a:p>
+            <a:pPr>
+              <a:spcBef>
+                <a:spcPts val="0"/>
+              </a:spcBef>
+              <a:spcAft>
+                <a:spcPts val="1200"/>
+              </a:spcAft>
+            </a:pPr>
+            <a:r>
+              <a:rPr sz="800">
+                <a:solidFill>
+                  <a:srgbClr val="000000"/>
+                </a:solidFill>
+                <a:latin typeface="Overpass Mono"/>
+              </a:rPr>
+              <a:t>Inter Semi Bold · 24px · section headings (--font-ui)</a:t>
+            </a:r>
+          </a:p>
+          <a:p>
+            <a:pPr>
+              <a:lnSpc>
+                <a:spcPct val="100000"/>
+              </a:lnSpc>
+              <a:spcBef>
+                <a:spcPts val="0"/>
+              </a:spcBef>
+              <a:spcAft>
+                <a:spcPts val="200"/>
+              </a:spcAft>
+            </a:pPr>
+            <a:r>
+              <a:rPr sz="1200">
+                <a:solidFill>
+                  <a:srgbClr val="000000"/>
+                </a:solidFill>
+                <a:latin typeface="Inter Medium"/>
+              </a:rPr>
+              <a:t>Imanol's team just launched Apertus.</a:t>
+            </a:r>
+          </a:p>
+          <a:p>
+            <a:pPr>
+              <a:spcBef>
+                <a:spcPts val="0"/>
+              </a:spcBef>
+              <a:spcAft>
+                <a:spcPts val="1200"/>
+              </a:spcAft>
+            </a:pPr>
+            <a:r>
+              <a:rPr sz="800">
+                <a:solidFill>
+                  <a:srgbClr val="000000"/>
+                </a:solidFill>
+                <a:latin typeface="Overpass Mono"/>
+              </a:rPr>
+              <a:t>Inter Medium · 18px · UI text &amp; card titles</a:t>
+            </a:r>
+          </a:p>
+          <a:p>
+            <a:pPr>
+              <a:lnSpc>
+                <a:spcPct val="100000"/>
+              </a:lnSpc>
+              <a:spcBef>
+                <a:spcPts val="0"/>
+              </a:spcBef>
+              <a:spcAft>
+                <a:spcPts val="200"/>
+              </a:spcAft>
+            </a:pPr>
+            <a:r>
+              <a:rPr sz="1100">
+                <a:solidFill>
+                  <a:srgbClr val="000000"/>
                 </a:solidFill>
                 <a:latin typeface="Public Sans"/>
               </a:rPr>
-              <a:t>Example extension — mark + retyped wordmark for a sub-brand or product lockup:</a:t>
-            </a:r>
-          </a:p>
-        </p:txBody>
-      </p:sp>
-      <p:sp>
-        <p:nvSpPr>
-          <p:cNvPr id="8" name="Rectangle 7"/>
-          <p:cNvSpPr/>
-          <p:nvPr/>
-        </p:nvSpPr>
-        <p:spPr>
-          <a:xfrm>
-            <a:off x="822960" y="4023360"/>
-            <a:ext cx="914400" cy="839724"/>
-          </a:xfrm>
-          <a:prstGeom prst="rect">
-            <a:avLst/>
-          </a:prstGeom>
-          <a:solidFill>
-            <a:srgbClr val="EF3C24"/>
-          </a:solidFill>
-          <a:ln>
-            <a:noFill/>
-          </a:ln>
-        </p:spPr>
-        <p:style>
-          <a:lnRef idx="1">
-            <a:schemeClr val="accent1"/>
-          </a:lnRef>
-          <a:fillRef idx="3">
-            <a:schemeClr val="accent1"/>
-          </a:fillRef>
-          <a:effectRef idx="2">
-            <a:schemeClr val="accent1"/>
-          </a:effectRef>
-          <a:fontRef idx="minor">
-            <a:schemeClr val="lt1"/>
-          </a:fontRef>
-        </p:style>
-        <p:txBody>
-          <a:bodyPr rtlCol="0" anchor="ctr"/>
-          <a:lstStyle/>
-          <a:p>
-            <a:pPr algn="ctr"/>
-          </a:p>
-        </p:txBody>
-      </p:sp>
-      <p:sp>
-        <p:nvSpPr>
-          <p:cNvPr id="9" name="Freeform 8"/>
-          <p:cNvSpPr/>
-          <p:nvPr/>
-        </p:nvSpPr>
-        <p:spPr>
-          <a:xfrm>
-            <a:off x="1036320" y="4168140"/>
-            <a:ext cx="487680" cy="519684"/>
-          </a:xfrm>
-          <a:custGeom>
-            <a:avLst/>
-            <a:gdLst/>
-            <a:ahLst/>
-            <a:cxnLst/>
-            <a:rect l="l" t="t" r="r" b="b"/>
-            <a:pathLst>
-              <a:path w="320" h="341">
-                <a:moveTo>
-                  <a:pt x="0" y="259"/>
-                </a:moveTo>
-                <a:lnTo>
-                  <a:pt x="0" y="200"/>
-                </a:lnTo>
-                <a:lnTo>
-                  <a:pt x="249" y="130"/>
-                </a:lnTo>
-                <a:lnTo>
-                  <a:pt x="0" y="59"/>
-                </a:lnTo>
-                <a:lnTo>
-                  <a:pt x="0" y="0"/>
-                </a:lnTo>
-                <a:lnTo>
-                  <a:pt x="320" y="98"/>
-                </a:lnTo>
-                <a:lnTo>
-                  <a:pt x="320" y="162"/>
-                </a:lnTo>
-                <a:close/>
-                <a:moveTo>
-                  <a:pt x="0" y="341"/>
-                </a:moveTo>
-                <a:lnTo>
-                  <a:pt x="0" y="288"/>
-                </a:lnTo>
-                <a:lnTo>
-                  <a:pt x="320" y="288"/>
-                </a:lnTo>
-                <a:lnTo>
-                  <a:pt x="320" y="341"/>
-                </a:lnTo>
-                <a:close/>
-              </a:path>
-            </a:pathLst>
-          </a:custGeom>
-          <a:solidFill>
-            <a:srgbClr val="FFFFFF"/>
-          </a:solidFill>
-          <a:ln>
-            <a:noFill/>
-          </a:ln>
-        </p:spPr>
-        <p:style>
-          <a:lnRef idx="1">
-            <a:schemeClr val="accent1"/>
-          </a:lnRef>
-          <a:fillRef idx="3">
-            <a:schemeClr val="accent1"/>
-          </a:fillRef>
-          <a:effectRef idx="2">
-            <a:schemeClr val="accent1"/>
-          </a:effectRef>
-          <a:fontRef idx="minor">
-            <a:schemeClr val="lt1"/>
-          </a:fontRef>
-        </p:style>
-        <p:txBody>
-          <a:bodyPr rtlCol="0" anchor="ctr"/>
-          <a:lstStyle/>
-          <a:p>
-            <a:pPr algn="ctr"/>
-          </a:p>
-        </p:txBody>
-      </p:sp>
-      <p:sp>
-        <p:nvSpPr>
-          <p:cNvPr id="10" name="TextBox 9"/>
-          <p:cNvSpPr txBox="1"/>
-          <p:nvPr/>
-        </p:nvSpPr>
-        <p:spPr>
-          <a:xfrm>
-            <a:off x="1920240" y="4023360"/>
-            <a:ext cx="8229600" cy="914400"/>
-          </a:xfrm>
-          <a:prstGeom prst="rect">
-            <a:avLst/>
-          </a:prstGeom>
-          <a:noFill/>
-        </p:spPr>
-        <p:txBody>
-          <a:bodyPr wrap="square" anchor="ctr">
-            <a:spAutoFit/>
-          </a:bodyPr>
-          <a:lstStyle/>
-          <a:p>
-            <a:pPr algn="l"/>
-            <a:r>
-              <a:rPr sz="3600" b="1">
+              <a:t>AI as public infrastructure, built in the open. We're looking for open source contributors.</a:t>
+            </a:r>
+          </a:p>
+          <a:p>
+            <a:pPr>
+              <a:spcBef>
+                <a:spcPts val="0"/>
+              </a:spcBef>
+              <a:spcAft>
+                <a:spcPts val="1200"/>
+              </a:spcAft>
+            </a:pPr>
+            <a:r>
+              <a:rPr sz="800">
                 <a:solidFill>
                   <a:srgbClr val="000000"/>
                 </a:solidFill>
-                <a:latin typeface="NB International Pro CG"/>
+                <a:latin typeface="Overpass Mono"/>
               </a:rPr>
-              <a:t>Public AI Labs</a:t>
+              <a:t>Public Sans Regular · 15px · body copy · lh 1.4 (--font-sans)</a:t>
+            </a:r>
+          </a:p>
+          <a:p>
+            <a:pPr>
+              <a:lnSpc>
+                <a:spcPct val="100000"/>
+              </a:lnSpc>
+              <a:spcBef>
+                <a:spcPts val="0"/>
+              </a:spcBef>
+              <a:spcAft>
+                <a:spcPts val="200"/>
+              </a:spcAft>
+            </a:pPr>
+            <a:r>
+              <a:rPr sz="1000" b="1">
+                <a:solidFill>
+                  <a:srgbClr val="000000"/>
+                </a:solidFill>
+                <a:latin typeface="Public Sans SemiBold"/>
+              </a:rPr>
+              <a:t>TRY IT</a:t>
+            </a:r>
+          </a:p>
+          <a:p>
+            <a:pPr>
+              <a:spcBef>
+                <a:spcPts val="0"/>
+              </a:spcBef>
+              <a:spcAft>
+                <a:spcPts val="1200"/>
+              </a:spcAft>
+            </a:pPr>
+            <a:r>
+              <a:rPr sz="800">
+                <a:solidFill>
+                  <a:srgbClr val="000000"/>
+                </a:solidFill>
+                <a:latin typeface="Overpass Mono"/>
+              </a:rPr>
+              <a:t>Public Sans SemiBold · 14px · button labels, uppercase (--type-button)</a:t>
+            </a:r>
+          </a:p>
+          <a:p>
+            <a:pPr>
+              <a:lnSpc>
+                <a:spcPct val="100000"/>
+              </a:lnSpc>
+              <a:spcBef>
+                <a:spcPts val="0"/>
+              </a:spcBef>
+              <a:spcAft>
+                <a:spcPts val="200"/>
+              </a:spcAft>
+            </a:pPr>
+            <a:r>
+              <a:rPr sz="900">
+                <a:solidFill>
+                  <a:srgbClr val="000000"/>
+                </a:solidFill>
+                <a:latin typeface="Overpass Mono"/>
+              </a:rPr>
+              <a:t>OVERPASS MONO 12 — TABLE ITEMS, SPEC LABELS</a:t>
+            </a:r>
+          </a:p>
+          <a:p>
+            <a:pPr>
+              <a:spcBef>
+                <a:spcPts val="0"/>
+              </a:spcBef>
+              <a:spcAft>
+                <a:spcPts val="1000"/>
+              </a:spcAft>
+            </a:pPr>
+            <a:r>
+              <a:rPr sz="800">
+                <a:solidFill>
+                  <a:srgbClr val="000000"/>
+                </a:solidFill>
+                <a:latin typeface="Overpass Mono"/>
+              </a:rPr>
+              <a:t>Overpass Mono · 12px · spec labels, table items, captions (--font-mono)</a:t>
+            </a:r>
+          </a:p>
+          <a:p>
+            <a:pPr>
+              <a:lnSpc>
+                <a:spcPct val="100000"/>
+              </a:lnSpc>
+              <a:spcBef>
+                <a:spcPts val="0"/>
+              </a:spcBef>
+              <a:spcAft>
+                <a:spcPts val="200"/>
+              </a:spcAft>
+            </a:pPr>
+            <a:r>
+              <a:rPr sz="900" b="1">
+                <a:solidFill>
+                  <a:srgbClr val="000000"/>
+                </a:solidFill>
+                <a:latin typeface="Roboto Flex"/>
+              </a:rPr>
+              <a:t>Roboto Flex Medium 12 — tiny annotation labels</a:t>
+            </a:r>
+          </a:p>
+          <a:p>
+            <a:pPr>
+              <a:spcBef>
+                <a:spcPts val="0"/>
+              </a:spcBef>
+              <a:spcAft>
+                <a:spcPts val="400"/>
+              </a:spcAft>
+            </a:pPr>
+            <a:r>
+              <a:rPr sz="800">
+                <a:solidFill>
+                  <a:srgbClr val="000000"/>
+                </a:solidFill>
+                <a:latin typeface="Overpass Mono"/>
+              </a:rPr>
+              <a:t>Roboto Flex Medium · 12px · tiny annotations · ls −3% (--font-micro)</a:t>
             </a:r>
           </a:p>
         </p:txBody>
       </p:sp>
     </p:spTree>
+    <p:extLst>
+      <p:ext uri="{BB962C8B-B14F-4D97-AF65-F5344CB8AC3E}">
+        <p14:creationId xmlns:p14="http://schemas.microsoft.com/office/powerpoint/2010/main" val="1788873175"/>
+      </p:ext>
+    </p:extLst>
   </p:cSld>
   <p:clrMapOvr>
     <a:masterClrMapping/>

</xml_diff>